<commit_message>
fix(deps): override vulnerable transitive npm dependencies
Pin patched @xmldom/xmldom, basic-ftp and @puppeteer/browsers for Marp CLI and
image-size for pptxgenjs; npm audit is clean and both decks still build.

Co-authored-by: Copilot App <223556219+Copilot@users.noreply.github.com>
</commit_message>
<xml_diff>
--- a/docs/presentations/apim-ai-gateway-session.pptx
+++ b/docs/presentations/apim-ai-gateway-session.pptx
@@ -254,7 +254,7 @@
           </c:val>
           <c:extLst>
             <c:ext xmlns:c16="http://schemas.microsoft.com/office/drawing/2014/chart" uri="{C3380CC4-5D6E-409C-BE32-E72D297353CC}">
-              <c16:uniqueId val="{00000000-279A-42BD-AF2C-DB26D3E0B728}"/>
+              <c16:uniqueId val="{00000000-AD11-45D1-A05D-07DF4DFD78AE}"/>
             </c:ext>
           </c:extLst>
         </c:ser>
@@ -412,7 +412,7 @@
     </p:spTree>
     <p:extLst>
       <p:ext uri="{BB962C8B-B14F-4D97-AF65-F5344CB8AC3E}">
-        <p14:creationId xmlns:p14="http://schemas.microsoft.com/office/powerpoint/2010/main" val="3989709971"/>
+        <p14:creationId xmlns:p14="http://schemas.microsoft.com/office/powerpoint/2010/main" val="2337263678"/>
       </p:ext>
     </p:extLst>
   </p:cSld>

</xml_diff>

<commit_message>
fix(deps): override vulnerable transitive npm dependencies (#2)
Pin patched @xmldom/xmldom, basic-ftp and @puppeteer/browsers for Marp CLI and
image-size for pptxgenjs; npm audit is clean and both decks still build.

Co-authored-by: Copilot App <223556219+Copilot@users.noreply.github.com>
</commit_message>
<xml_diff>
--- a/docs/presentations/apim-ai-gateway-session.pptx
+++ b/docs/presentations/apim-ai-gateway-session.pptx
@@ -254,7 +254,7 @@
           </c:val>
           <c:extLst>
             <c:ext xmlns:c16="http://schemas.microsoft.com/office/drawing/2014/chart" uri="{C3380CC4-5D6E-409C-BE32-E72D297353CC}">
-              <c16:uniqueId val="{00000000-279A-42BD-AF2C-DB26D3E0B728}"/>
+              <c16:uniqueId val="{00000000-AD11-45D1-A05D-07DF4DFD78AE}"/>
             </c:ext>
           </c:extLst>
         </c:ser>
@@ -412,7 +412,7 @@
     </p:spTree>
     <p:extLst>
       <p:ext uri="{BB962C8B-B14F-4D97-AF65-F5344CB8AC3E}">
-        <p14:creationId xmlns:p14="http://schemas.microsoft.com/office/powerpoint/2010/main" val="3989709971"/>
+        <p14:creationId xmlns:p14="http://schemas.microsoft.com/office/powerpoint/2010/main" val="2337263678"/>
       </p:ext>
     </p:extLst>
   </p:cSld>

</xml_diff>

<commit_message>
feat: move to Microsoft Foundry (new) projects and GPT-6.1 Sol
- Foundry resource + Foundry project per region (API 2026-07-01), visible in
  the current Foundry portal; Foundry User role for the operator
- APIM backends target the Foundry endpoint (*.services.ai.azure.com/openai/v1)
- Model gpt-6.1-sol 2026-09-29, GlobalStandard 100K TPM (was gpt-5.4-nano)
- Agent scenario uses the Responses API (function tools from MCP), stateless
  across load-balanced regions
- Decks, narrative, docs, ADR-0005 and narrated video updated with live results

Co-authored-by: Copilot App <223556219+Copilot@users.noreply.github.com>
</commit_message>
<xml_diff>
--- a/docs/presentations/apim-ai-gateway-session.pptx
+++ b/docs/presentations/apim-ai-gateway-session.pptx
@@ -254,7 +254,7 @@
           </c:val>
           <c:extLst>
             <c:ext xmlns:c16="http://schemas.microsoft.com/office/drawing/2014/chart" uri="{C3380CC4-5D6E-409C-BE32-E72D297353CC}">
-              <c16:uniqueId val="{00000000-AD11-45D1-A05D-07DF4DFD78AE}"/>
+              <c16:uniqueId val="{00000000-B145-44FA-85E1-749C44F1980D}"/>
             </c:ext>
           </c:extLst>
         </c:ser>
@@ -412,7 +412,7 @@
     </p:spTree>
     <p:extLst>
       <p:ext uri="{BB962C8B-B14F-4D97-AF65-F5344CB8AC3E}">
-        <p14:creationId xmlns:p14="http://schemas.microsoft.com/office/powerpoint/2010/main" val="2337263678"/>
+        <p14:creationId xmlns:p14="http://schemas.microsoft.com/office/powerpoint/2010/main" val="2312993810"/>
       </p:ext>
     </p:extLst>
   </p:cSld>
@@ -558,7 +558,7 @@
           <a:p>
             <a:r>
               <a:rPr lang="en-US"/>
-              <a:t>Open with the promise of the session: one control point for every AI call. Set expectations that this is a technical, demo-led walkthrough using Basic v2, Microsoft Foundry in Sweden Central and France Central, and gpt-5.4-nano. Emphasize that the deck doubles as a fallback narrative if the live demo environment misbehaves.</a:t>
+              <a:t>Open with the promise of the session: one control point for every AI call. Set expectations that this is a technical, demo-led walkthrough using Basic v2, Microsoft Foundry resources and projects in Sweden Central and France Central, and gpt-6.1-sol. Emphasize that the deck doubles as a fallback narrative if the live demo environment misbehaves.</a:t>
             </a:r>
             <a:endParaRPr lang="en-US" dirty="0"/>
           </a:p>
@@ -1086,7 +1086,7 @@
           <a:p>
             <a:r>
               <a:rPr lang="en-US"/>
-              <a:t>MCP and agents are important because enterprises are moving from direct model calls to tool-using systems. APIM can expose existing REST APIs as MCP servers, pass through existing MCP servers, and import A2A agent APIs. Stress the limits: MCP is tools-only today, not available in Consumption, and not supported inside workspaces.</a:t>
+              <a:t>MCP and agents are important because enterprises are moving from direct model calls to tool-using systems. APIM can expose existing REST APIs as MCP servers, pass through existing MCP servers, and import A2A agent APIs. D6 uses the Responses API with tools converted from the MCP tool list, and the same gateway policies apply to Chat Completions and Responses API traffic. Stress the limits: MCP is tools-only today, not available in Consumption, and not supported inside workspaces.</a:t>
             </a:r>
             <a:endParaRPr lang="en-US" dirty="0"/>
           </a:p>
@@ -1174,7 +1174,7 @@
           <a:p>
             <a:r>
               <a:rPr lang="en-US"/>
-              <a:t>Use this divider to switch from concepts to the deployed repository. Remind the audience that the live demo uses Basic v2, two Foundry accounts, gpt-5.4-nano, product-scoped token budgets, content safety, MCP and observability.</a:t>
+              <a:t>Use this divider to switch from concepts to the deployed repository. Remind the audience that the live demo uses Basic v2, two Foundry resources plus projects, gpt-6.1-sol, product-scoped token budgets, content safety, MCP and observability.</a:t>
             </a:r>
             <a:endParaRPr lang="en-US" dirty="0"/>
           </a:p>
@@ -1262,7 +1262,7 @@
           <a:p>
             <a:r>
               <a:rPr lang="en-US"/>
-              <a:t>This is the main architecture diagram and is drawn with editable native shapes. Read it left to right: apps and agents call APIM, policies execute as a chain, model traffic goes to the Foundry backend pool, and tool traffic goes through the MCP server to the mocked Zava Retail API. Observability is emitted to Application Insights and Log Analytics.</a:t>
+              <a:t>This is the main architecture diagram and is drawn with editable native shapes. Read it left to right: apps and agents call APIM, policies execute as a chain, model traffic goes to the current Foundry resource plus project in each region, and tool traffic goes through the MCP server to the mocked Zava Retail API. APIM backends call the Foundry OpenAI v1 endpoint with managed identity and key auth disabled. Observability is emitted to Application Insights and Log Analytics.</a:t>
             </a:r>
             <a:endParaRPr lang="en-US" dirty="0"/>
           </a:p>
@@ -1438,7 +1438,7 @@
           <a:p>
             <a:r>
               <a:rPr lang="en-US"/>
-              <a:t>If the live environment is unavailable, use this as the screenshot-style talk track. D1 proves keyless backend access and stable client code with the verified France Central response. D2 proves that load balancing is active by alternating requests across Sweden Central and France Central.</a:t>
+              <a:t>If the live environment is unavailable, use this as the screenshot-style talk track. D1 proves keyless backend access and stable client code with the verified Sweden Central response: 44 prompt tokens, 94 completion tokens and 19,862 remaining. D2 proves that load balancing is active by alternating requests across France Central and Sweden Central.</a:t>
             </a:r>
             <a:endParaRPr lang="en-US" dirty="0"/>
           </a:p>
@@ -1790,7 +1790,7 @@
           <a:p>
             <a:r>
               <a:rPr lang="en-US"/>
-              <a:t>D5 proves that an existing REST API can become an MCP server through APIM. D6 then shows the agentic behavior: the model chooses to call tools via the gateway. If showing this as a fallback, read the expected answer and point back to the architecture slide.</a:t>
+              <a:t>D5 proves that an existing REST API can become an MCP server through APIM; get-order-status returns ORD-1042 as out for delivery. D6 uses the Responses API through APIM at /inference/openai/v1/responses. The client converts the MCP tool list into function tools, sends store=false, resends encrypted reasoning items for stateless load-balanced turns, and model turns were served by both France Central and Sweden Central.</a:t>
             </a:r>
             <a:endParaRPr lang="en-US" dirty="0"/>
           </a:p>
@@ -3462,7 +3462,7 @@
           <a:p>
             <a:r>
               <a:rPr lang="en-US"/>
-              <a:t>This slide is intentionally dated. The point is that APIM is not only an API product anymore; it has first-class patterns for model APIs, MCP servers and A2A agents. Cite the updated Learn pages and research brief when challenged on dates.</a:t>
+              <a:t>This slide is intentionally dated. The point is that APIM is not only an API product anymore; it has first-class patterns for model APIs, MCP servers and A2A agents. The deployed Foundry platform is the current resource plus project model in ai.azure.com, not the classic hub-based project pattern. Cite the updated Learn pages and research brief when challenged on dates.</a:t>
             </a:r>
             <a:endParaRPr lang="en-US" dirty="0"/>
           </a:p>
@@ -4247,7 +4247,7 @@
                 <a:ea typeface="Segoe UI Semibold" pitchFamily="34" charset="-122"/>
                 <a:cs typeface="Segoe UI Semibold" pitchFamily="34" charset="-120"/>
               </a:rPr>
-              <a:t>gpt-5.4-nano</a:t>
+              <a:t>gpt-6.1-sol</a:t>
             </a:r>
             <a:endParaRPr lang="en-US" sz="750" dirty="0"/>
           </a:p>
@@ -5777,7 +5777,7 @@
                 <a:ea typeface="Segoe UI Semibold" pitchFamily="34" charset="-122"/>
                 <a:cs typeface="Segoe UI Semibold" pitchFamily="34" charset="-120"/>
               </a:rPr>
-              <a:t>Demo: jailbreak blocked before it reaches gpt-5.4-nano.</a:t>
+              <a:t>Demo: jailbreak blocked before it reaches gpt-6.1-sol.</a:t>
             </a:r>
             <a:endParaRPr lang="en-US" sz="1100" dirty="0"/>
           </a:p>
@@ -8652,7 +8652,7 @@
                 <a:ea typeface="Consolas" pitchFamily="34" charset="-122"/>
                 <a:cs typeface="Consolas" pitchFamily="34" charset="-120"/>
               </a:rPr>
-              <a:t>| where DeploymentName == "gpt-5.4-nano"</a:t>
+              <a:t>| where DeploymentName == "gpt-6.1-sol"</a:t>
             </a:r>
             <a:endParaRPr lang="en-US" sz="1130" dirty="0"/>
           </a:p>
@@ -10928,7 +10928,7 @@
                 <a:ea typeface="Segoe UI Semibold" pitchFamily="34" charset="-122"/>
                 <a:cs typeface="Segoe UI Semibold" pitchFamily="34" charset="-120"/>
               </a:rPr>
-              <a:t>Zava Retail REST API becomes /zava-mcp/mcp with tools: search-products and get-order-status.</a:t>
+              <a:t>D6: Responses API turns the MCP tool list into function tools; APIM policies still apply.</a:t>
             </a:r>
             <a:endParaRPr lang="en-US" sz="1200" dirty="0"/>
           </a:p>
@@ -12134,12 +12134,12 @@
         </p:nvSpPr>
         <p:spPr>
           <a:xfrm>
-            <a:off x="8138160" y="1188720"/>
-            <a:ext cx="2651760" cy="868680"/>
+            <a:off x="7973568" y="1005840"/>
+            <a:ext cx="2971800" cy="1078992"/>
           </a:xfrm>
           <a:prstGeom prst="roundRect">
             <a:avLst>
-              <a:gd name="adj" fmla="val 6316"/>
+              <a:gd name="adj" fmla="val 5085"/>
             </a:avLst>
           </a:prstGeom>
           <a:solidFill>
@@ -12161,8 +12161,8 @@
         </p:nvSpPr>
         <p:spPr>
           <a:xfrm>
-            <a:off x="8247888" y="1280160"/>
-            <a:ext cx="2432304" cy="685800"/>
+            <a:off x="8083296" y="1097280"/>
+            <a:ext cx="2752344" cy="896112"/>
           </a:xfrm>
           <a:prstGeom prst="rect">
             <a:avLst/>
@@ -12180,7 +12180,7 @@
               <a:buNone/>
             </a:pPr>
             <a:r>
-              <a:rPr lang="en-US" sz="1000" dirty="0">
+              <a:rPr lang="en-US" sz="750" dirty="0">
                 <a:solidFill>
                   <a:srgbClr val="0B1E3F"/>
                 </a:solidFill>
@@ -12188,16 +12188,16 @@
                 <a:ea typeface="Segoe UI Semibold" pitchFamily="34" charset="-122"/>
                 <a:cs typeface="Segoe UI Semibold" pitchFamily="34" charset="-120"/>
               </a:rPr>
-              <a:t>Foundry Sweden Central</a:t>
-            </a:r>
-            <a:endParaRPr lang="en-US" sz="1000" dirty="0"/>
+              <a:t>Foundry project · Sweden Central</a:t>
+            </a:r>
+            <a:endParaRPr lang="en-US" sz="750" dirty="0"/>
           </a:p>
           <a:p>
             <a:pPr marL="0" indent="0" algn="ctr">
               <a:buNone/>
             </a:pPr>
             <a:r>
-              <a:rPr lang="en-US" sz="1000" dirty="0">
+              <a:rPr lang="en-US" sz="750" dirty="0">
                 <a:solidFill>
                   <a:srgbClr val="0B1E3F"/>
                 </a:solidFill>
@@ -12205,9 +12205,43 @@
                 <a:ea typeface="Segoe UI Semibold" pitchFamily="34" charset="-122"/>
                 <a:cs typeface="Segoe UI Semibold" pitchFamily="34" charset="-120"/>
               </a:rPr>
-              <a:t>gpt-5.4-nano</a:t>
-            </a:r>
-            <a:endParaRPr lang="en-US" sz="1000" dirty="0"/>
+              <a:t>proj-apimaigw-swc</a:t>
+            </a:r>
+            <a:endParaRPr lang="en-US" sz="750" dirty="0"/>
+          </a:p>
+          <a:p>
+            <a:pPr marL="0" indent="0" algn="ctr">
+              <a:buNone/>
+            </a:pPr>
+            <a:r>
+              <a:rPr lang="en-US" sz="750" dirty="0">
+                <a:solidFill>
+                  <a:srgbClr val="0B1E3F"/>
+                </a:solidFill>
+                <a:latin typeface="Segoe UI Semibold" pitchFamily="34" charset="0"/>
+                <a:ea typeface="Segoe UI Semibold" pitchFamily="34" charset="-122"/>
+                <a:cs typeface="Segoe UI Semibold" pitchFamily="34" charset="-120"/>
+              </a:rPr>
+              <a:t>gpt-6.1-sol · GlobalStandard</a:t>
+            </a:r>
+            <a:endParaRPr lang="en-US" sz="750" dirty="0"/>
+          </a:p>
+          <a:p>
+            <a:pPr marL="0" indent="0" algn="ctr">
+              <a:buNone/>
+            </a:pPr>
+            <a:r>
+              <a:rPr lang="en-US" sz="750" dirty="0">
+                <a:solidFill>
+                  <a:srgbClr val="0B1E3F"/>
+                </a:solidFill>
+                <a:latin typeface="Segoe UI Semibold" pitchFamily="34" charset="0"/>
+                <a:ea typeface="Segoe UI Semibold" pitchFamily="34" charset="-122"/>
+                <a:cs typeface="Segoe UI Semibold" pitchFamily="34" charset="-120"/>
+              </a:rPr>
+              <a:t>v2026-09-29 · 100K TPM</a:t>
+            </a:r>
+            <a:endParaRPr lang="en-US" sz="750" dirty="0"/>
           </a:p>
         </p:txBody>
       </p:sp>
@@ -12219,12 +12253,12 @@
         </p:nvSpPr>
         <p:spPr>
           <a:xfrm>
-            <a:off x="8138160" y="2377440"/>
-            <a:ext cx="2651760" cy="868680"/>
+            <a:off x="7973568" y="2331720"/>
+            <a:ext cx="2971800" cy="1078992"/>
           </a:xfrm>
           <a:prstGeom prst="roundRect">
             <a:avLst>
-              <a:gd name="adj" fmla="val 6316"/>
+              <a:gd name="adj" fmla="val 5085"/>
             </a:avLst>
           </a:prstGeom>
           <a:solidFill>
@@ -12246,8 +12280,8 @@
         </p:nvSpPr>
         <p:spPr>
           <a:xfrm>
-            <a:off x="8247888" y="2468880"/>
-            <a:ext cx="2432304" cy="685800"/>
+            <a:off x="8083296" y="2423160"/>
+            <a:ext cx="2752344" cy="896112"/>
           </a:xfrm>
           <a:prstGeom prst="rect">
             <a:avLst/>
@@ -12265,7 +12299,7 @@
               <a:buNone/>
             </a:pPr>
             <a:r>
-              <a:rPr lang="en-US" sz="1000" dirty="0">
+              <a:rPr lang="en-US" sz="750" dirty="0">
                 <a:solidFill>
                   <a:srgbClr val="0B1E3F"/>
                 </a:solidFill>
@@ -12273,16 +12307,16 @@
                 <a:ea typeface="Segoe UI Semibold" pitchFamily="34" charset="-122"/>
                 <a:cs typeface="Segoe UI Semibold" pitchFamily="34" charset="-120"/>
               </a:rPr>
-              <a:t>Foundry France Central</a:t>
-            </a:r>
-            <a:endParaRPr lang="en-US" sz="1000" dirty="0"/>
+              <a:t>Foundry project · France Central</a:t>
+            </a:r>
+            <a:endParaRPr lang="en-US" sz="750" dirty="0"/>
           </a:p>
           <a:p>
             <a:pPr marL="0" indent="0" algn="ctr">
               <a:buNone/>
             </a:pPr>
             <a:r>
-              <a:rPr lang="en-US" sz="1000" dirty="0">
+              <a:rPr lang="en-US" sz="750" dirty="0">
                 <a:solidFill>
                   <a:srgbClr val="0B1E3F"/>
                 </a:solidFill>
@@ -12290,9 +12324,43 @@
                 <a:ea typeface="Segoe UI Semibold" pitchFamily="34" charset="-122"/>
                 <a:cs typeface="Segoe UI Semibold" pitchFamily="34" charset="-120"/>
               </a:rPr>
-              <a:t>gpt-5.4-nano</a:t>
-            </a:r>
-            <a:endParaRPr lang="en-US" sz="1000" dirty="0"/>
+              <a:t>proj-apimaigw-frc</a:t>
+            </a:r>
+            <a:endParaRPr lang="en-US" sz="750" dirty="0"/>
+          </a:p>
+          <a:p>
+            <a:pPr marL="0" indent="0" algn="ctr">
+              <a:buNone/>
+            </a:pPr>
+            <a:r>
+              <a:rPr lang="en-US" sz="750" dirty="0">
+                <a:solidFill>
+                  <a:srgbClr val="0B1E3F"/>
+                </a:solidFill>
+                <a:latin typeface="Segoe UI Semibold" pitchFamily="34" charset="0"/>
+                <a:ea typeface="Segoe UI Semibold" pitchFamily="34" charset="-122"/>
+                <a:cs typeface="Segoe UI Semibold" pitchFamily="34" charset="-120"/>
+              </a:rPr>
+              <a:t>gpt-6.1-sol · GlobalStandard</a:t>
+            </a:r>
+            <a:endParaRPr lang="en-US" sz="750" dirty="0"/>
+          </a:p>
+          <a:p>
+            <a:pPr marL="0" indent="0" algn="ctr">
+              <a:buNone/>
+            </a:pPr>
+            <a:r>
+              <a:rPr lang="en-US" sz="750" dirty="0">
+                <a:solidFill>
+                  <a:srgbClr val="0B1E3F"/>
+                </a:solidFill>
+                <a:latin typeface="Segoe UI Semibold" pitchFamily="34" charset="0"/>
+                <a:ea typeface="Segoe UI Semibold" pitchFamily="34" charset="-122"/>
+                <a:cs typeface="Segoe UI Semibold" pitchFamily="34" charset="-120"/>
+              </a:rPr>
+              <a:t>v2026-09-29 · 100K TPM</a:t>
+            </a:r>
+            <a:endParaRPr lang="en-US" sz="750" dirty="0"/>
           </a:p>
         </p:txBody>
       </p:sp>
@@ -12583,8 +12651,8 @@
         </p:nvSpPr>
         <p:spPr>
           <a:xfrm>
-            <a:off x="7040880" y="1627632"/>
-            <a:ext cx="1097280" cy="0"/>
+            <a:off x="7040880" y="1545336"/>
+            <a:ext cx="932688" cy="0"/>
           </a:xfrm>
           <a:prstGeom prst="line">
             <a:avLst/>
@@ -12607,8 +12675,8 @@
         </p:nvSpPr>
         <p:spPr>
           <a:xfrm>
-            <a:off x="7040880" y="2816352"/>
-            <a:ext cx="1097280" cy="0"/>
+            <a:off x="7040880" y="2871216"/>
+            <a:ext cx="932688" cy="0"/>
           </a:xfrm>
           <a:prstGeom prst="line">
             <a:avLst/>
@@ -13156,7 +13224,7 @@
                 <a:ea typeface="Segoe UI" pitchFamily="34" charset="-122"/>
                 <a:cs typeface="Segoe UI" pitchFamily="34" charset="-120"/>
               </a:rPr>
-              <a:t>200 via France Central; token headers show 44 prompt / 51 completion and 19,905 remaining.</a:t>
+              <a:t>200 via Sweden Central; token headers show 44 prompt / 94 completion and 19,862 remaining.</a:t>
             </a:r>
             <a:endParaRPr lang="en-US" sz="820" dirty="0"/>
           </a:p>
@@ -13288,7 +13356,7 @@
                 <a:ea typeface="Segoe UI" pitchFamily="34" charset="-122"/>
                 <a:cs typeface="Segoe UI" pitchFamily="34" charset="-120"/>
               </a:rPr>
-              <a:t>Six calls spread across Sweden Central and France Central; circuit breaker explained.</a:t>
+              <a:t>Six calls alternate France Central and Sweden Central; circuit breaker explained.</a:t>
             </a:r>
             <a:endParaRPr lang="en-US" sz="820" dirty="0"/>
           </a:p>
@@ -13420,7 +13488,7 @@
                 <a:ea typeface="Segoe UI" pitchFamily="34" charset="-122"/>
                 <a:cs typeface="Segoe UI" pitchFamily="34" charset="-120"/>
               </a:rPr>
-              <a:t>Bronze hits 429 with Retry-After; Gold continues; monthly quota returns 403.</a:t>
+              <a:t>Bronze returns 200 x6 then 429 Retry-After 11; Gold continues.</a:t>
             </a:r>
             <a:endParaRPr lang="en-US" sz="820" dirty="0"/>
           </a:p>
@@ -13816,7 +13884,7 @@
                 <a:ea typeface="Segoe UI" pitchFamily="34" charset="-122"/>
                 <a:cs typeface="Segoe UI" pitchFamily="34" charset="-120"/>
               </a:rPr>
-              <a:t>Model calls MCP tools via gateway to answer product and order questions.</a:t>
+              <a:t>Responses API converts MCP tools to function tools; store=false keeps it stateless.</a:t>
             </a:r>
             <a:endParaRPr lang="en-US" sz="820" dirty="0"/>
           </a:p>
@@ -13948,7 +14016,7 @@
                 <a:ea typeface="Segoe UI" pitchFamily="34" charset="-122"/>
                 <a:cs typeface="Segoe UI" pitchFamily="34" charset="-120"/>
               </a:rPr>
-              <a:t>AppMetrics by Product and ApiManagementGatewayLlmLog by DeploymentName gpt-5.4-nano.</a:t>
+              <a:t>AppMetrics by Product and ApiManagementGatewayLlmLog by DeploymentName gpt-6.1-sol.</a:t>
             </a:r>
             <a:endParaRPr lang="en-US" sz="820" dirty="0"/>
           </a:p>
@@ -14569,7 +14637,7 @@
                 <a:ea typeface="Segoe UI" pitchFamily="34" charset="-122"/>
                 <a:cs typeface="Segoe UI" pitchFamily="34" charset="-120"/>
               </a:rPr>
-              <a:t>HTTP 200 via France Central. App uses only an APIM subscription key; APIM authenticates to Foundry with managed identity.</a:t>
+              <a:t>HTTP 200 via Sweden Central. App uses only an APIM subscription key; APIM authenticates to Foundry with managed identity.</a:t>
             </a:r>
             <a:endParaRPr lang="en-US" sz="1020" dirty="0"/>
           </a:p>
@@ -14772,7 +14840,7 @@
                 <a:ea typeface="Segoe UI" pitchFamily="34" charset="-122"/>
                 <a:cs typeface="Segoe UI" pitchFamily="34" charset="-120"/>
               </a:rPr>
-              <a:t>Six requests alternate Sweden Central / France Central. Circuit breaker remains ready for 429/5xx failover.</a:t>
+              <a:t>Six requests alternate France Central / Sweden Central. Circuit breaker remains ready for 429/5xx failover.</a:t>
             </a:r>
             <a:endParaRPr lang="en-US" sz="1020" dirty="0"/>
           </a:p>
@@ -14838,7 +14906,7 @@
                 <a:ea typeface="Consolas" pitchFamily="34" charset="-122"/>
                 <a:cs typeface="Consolas" pitchFamily="34" charset="-120"/>
               </a:rPr>
-              <a:t>D1: 200 OK · region=francecentral · prompt=44 · completion=51 · remaining=19905</a:t>
+              <a:t>D1: 200 OK · region=swedencentral · prompt=44 · completion=94 · remaining=19862</a:t>
             </a:r>
             <a:endParaRPr lang="en-US" sz="1000" dirty="0"/>
           </a:p>
@@ -14855,7 +14923,7 @@
                 <a:ea typeface="Consolas" pitchFamily="34" charset="-122"/>
                 <a:cs typeface="Consolas" pitchFamily="34" charset="-120"/>
               </a:rPr>
-              <a:t>D2: swedencentral → francecentral → swedencentral → francecentral → swedencentral → francecentral</a:t>
+              <a:t>D2: francecentral → swedencentral → francecentral → swedencentral → francecentral → swedencentral</a:t>
             </a:r>
             <a:endParaRPr lang="en-US" sz="1000" dirty="0"/>
           </a:p>
@@ -17497,7 +17565,7 @@
                 <a:ea typeface="Segoe UI" pitchFamily="34" charset="-122"/>
                 <a:cs typeface="Segoe UI" pitchFamily="34" charset="-120"/>
               </a:rPr>
-              <a:t>Bronze returns 200 five times, then 429 with Retry-After; Gold still returns 200.</a:t>
+              <a:t>Bronze returns 200 six times, then 429 with Retry-After 11; Gold still returns 200.</a:t>
             </a:r>
             <a:endParaRPr lang="en-US" sz="1040" dirty="0"/>
           </a:p>
@@ -17563,7 +17631,7 @@
                 <a:ea typeface="Consolas" pitchFamily="34" charset="-122"/>
                 <a:cs typeface="Consolas" pitchFamily="34" charset="-120"/>
               </a:rPr>
-              <a:t>Bronze calls: 200 x5 · remaining tokens: 228, 162, 104, 52, 0</a:t>
+              <a:t>Bronze calls: 200 x6 · remaining: 239, 176, 123, 81, 9, 0</a:t>
             </a:r>
             <a:endParaRPr lang="en-US" sz="1210" dirty="0"/>
           </a:p>
@@ -17580,7 +17648,7 @@
                 <a:ea typeface="Consolas" pitchFamily="34" charset="-122"/>
                 <a:cs typeface="Consolas" pitchFamily="34" charset="-120"/>
               </a:rPr>
-              <a:t>Then: HTTP/1.1 429 Too Many Requests · Retry-After returned</a:t>
+              <a:t>Then: HTTP/1.1 429 Too Many Requests · Retry-After: 11</a:t>
             </a:r>
             <a:endParaRPr lang="en-US" sz="1210" dirty="0"/>
           </a:p>
@@ -18057,7 +18125,7 @@
                 <a:ea typeface="Segoe UI" pitchFamily="34" charset="-122"/>
                 <a:cs typeface="Segoe UI" pitchFamily="34" charset="-120"/>
               </a:rPr>
-              <a:t>Verified HTTP 200; forwarded through APIM to gpt-5.4-nano.</a:t>
+              <a:t>Verified HTTP 200; forwarded through APIM to gpt-6.1-sol.</a:t>
             </a:r>
             <a:endParaRPr lang="en-US" sz="1050" dirty="0"/>
           </a:p>
@@ -18965,7 +19033,7 @@
                 <a:ea typeface="Segoe UI Semibold" pitchFamily="34" charset="-122"/>
                 <a:cs typeface="Segoe UI Semibold" pitchFamily="34" charset="-120"/>
               </a:rPr>
-              <a:t>D6: model decides</a:t>
+              <a:t>D6: Responses API</a:t>
             </a:r>
             <a:endParaRPr lang="en-US" sz="1250" dirty="0"/>
           </a:p>
@@ -19006,7 +19074,7 @@
                 <a:ea typeface="Segoe UI" pitchFamily="34" charset="-122"/>
                 <a:cs typeface="Segoe UI" pitchFamily="34" charset="-120"/>
               </a:rPr>
-              <a:t>Agent called both MCP tools through the gateway and composed the answer.</a:t>
+              <a:t>Agent converted MCP tools into function tools; store=false keeps the turn stateless.</a:t>
             </a:r>
             <a:endParaRPr lang="en-US" sz="1040" dirty="0"/>
           </a:p>
@@ -19189,7 +19257,7 @@
                 <a:ea typeface="Consolas" pitchFamily="34" charset="-122"/>
                 <a:cs typeface="Consolas" pitchFamily="34" charset="-120"/>
               </a:rPr>
-              <a:t>"Trail backpack 30L (€89.9) and Headlamp 400lm (€34.5) are under 100 EUR.</a:t>
+              <a:t>"Trail backpack 30L (€89.90) and Headlamp 400lm (€34.50) are under 100 EUR.</a:t>
             </a:r>
             <a:endParaRPr lang="en-US" sz="1020" dirty="0"/>
           </a:p>
@@ -19206,7 +19274,7 @@
                 <a:ea typeface="Consolas" pitchFamily="34" charset="-122"/>
                 <a:cs typeface="Consolas" pitchFamily="34" charset="-120"/>
               </a:rPr>
-              <a:t>ORD-1042 is Out for delivery with Zava Express."</a:t>
+              <a:t>ORD-1042 is out for delivery with Zava Express."</a:t>
             </a:r>
             <a:endParaRPr lang="en-US" sz="1020" dirty="0"/>
           </a:p>
@@ -19869,7 +19937,7 @@
                 <a:ea typeface="Segoe UI" pitchFamily="34" charset="-122"/>
                 <a:cs typeface="Segoe UI" pitchFamily="34" charset="-120"/>
               </a:rPr>
-              <a:t>ApiManagementGatewayLlmLog groups calls by DeploymentName: gpt-5.4-nano.</a:t>
+              <a:t>ApiManagementGatewayLlmLog groups calls by DeploymentName: gpt-6.1-sol.</a:t>
             </a:r>
             <a:endParaRPr lang="en-US" sz="1040" dirty="0"/>
           </a:p>
@@ -20155,7 +20223,7 @@
                 <a:ea typeface="Consolas" pitchFamily="34" charset="-122"/>
                 <a:cs typeface="Consolas" pitchFamily="34" charset="-120"/>
               </a:rPr>
-              <a:t>ApiManagementGatewayLlmLog | summarize Calls=count() by DeploymentName   // gpt-5.4-nano</a:t>
+              <a:t>ApiManagementGatewayLlmLog | summarize Calls=count() by DeploymentName   // gpt-6.1-sol</a:t>
             </a:r>
             <a:endParaRPr lang="en-US" sz="1060" dirty="0"/>
           </a:p>
@@ -37790,7 +37858,7 @@
                 <a:ea typeface="Segoe UI Semibold" pitchFamily="34" charset="-122"/>
                 <a:cs typeface="Segoe UI Semibold" pitchFamily="34" charset="-120"/>
               </a:rPr>
-              <a:t>2026 preview</a:t>
+              <a:t>Oct 2026</a:t>
             </a:r>
             <a:endParaRPr lang="en-US" sz="1000" dirty="0"/>
           </a:p>
@@ -37831,7 +37899,7 @@
                 <a:ea typeface="Segoe UI" pitchFamily="34" charset="-122"/>
                 <a:cs typeface="Segoe UI" pitchFamily="34" charset="-120"/>
               </a:rPr>
-              <a:t>Unified model API and Foundry-integrated AI gateway.</a:t>
+              <a:t>Foundry (new): resource + project per region in ai.azure.com; no classic hub or Azure OpenAI resource.</a:t>
             </a:r>
             <a:endParaRPr lang="en-US" sz="1120" dirty="0"/>
           </a:p>

</xml_diff>

<commit_message>
feat: move to Microsoft Foundry (new) projects and GPT-6.1 Sol (#3)
- Foundry resource + Foundry project per region (API 2026-07-01), visible in
  the current Foundry portal; Foundry User role for the operator
- APIM backends target the Foundry endpoint (*.services.ai.azure.com/openai/v1)
- Model gpt-6.1-sol 2026-09-29, GlobalStandard 100K TPM (was gpt-5.4-nano)
- Agent scenario uses the Responses API (function tools from MCP), stateless
  across load-balanced regions
- Decks, narrative, docs, ADR-0005 and narrated video updated with live results

Co-authored-by: Copilot App <223556219+Copilot@users.noreply.github.com>
</commit_message>
<xml_diff>
--- a/docs/presentations/apim-ai-gateway-session.pptx
+++ b/docs/presentations/apim-ai-gateway-session.pptx
@@ -254,7 +254,7 @@
           </c:val>
           <c:extLst>
             <c:ext xmlns:c16="http://schemas.microsoft.com/office/drawing/2014/chart" uri="{C3380CC4-5D6E-409C-BE32-E72D297353CC}">
-              <c16:uniqueId val="{00000000-AD11-45D1-A05D-07DF4DFD78AE}"/>
+              <c16:uniqueId val="{00000000-B145-44FA-85E1-749C44F1980D}"/>
             </c:ext>
           </c:extLst>
         </c:ser>
@@ -412,7 +412,7 @@
     </p:spTree>
     <p:extLst>
       <p:ext uri="{BB962C8B-B14F-4D97-AF65-F5344CB8AC3E}">
-        <p14:creationId xmlns:p14="http://schemas.microsoft.com/office/powerpoint/2010/main" val="2337263678"/>
+        <p14:creationId xmlns:p14="http://schemas.microsoft.com/office/powerpoint/2010/main" val="2312993810"/>
       </p:ext>
     </p:extLst>
   </p:cSld>
@@ -558,7 +558,7 @@
           <a:p>
             <a:r>
               <a:rPr lang="en-US"/>
-              <a:t>Open with the promise of the session: one control point for every AI call. Set expectations that this is a technical, demo-led walkthrough using Basic v2, Microsoft Foundry in Sweden Central and France Central, and gpt-5.4-nano. Emphasize that the deck doubles as a fallback narrative if the live demo environment misbehaves.</a:t>
+              <a:t>Open with the promise of the session: one control point for every AI call. Set expectations that this is a technical, demo-led walkthrough using Basic v2, Microsoft Foundry resources and projects in Sweden Central and France Central, and gpt-6.1-sol. Emphasize that the deck doubles as a fallback narrative if the live demo environment misbehaves.</a:t>
             </a:r>
             <a:endParaRPr lang="en-US" dirty="0"/>
           </a:p>
@@ -1086,7 +1086,7 @@
           <a:p>
             <a:r>
               <a:rPr lang="en-US"/>
-              <a:t>MCP and agents are important because enterprises are moving from direct model calls to tool-using systems. APIM can expose existing REST APIs as MCP servers, pass through existing MCP servers, and import A2A agent APIs. Stress the limits: MCP is tools-only today, not available in Consumption, and not supported inside workspaces.</a:t>
+              <a:t>MCP and agents are important because enterprises are moving from direct model calls to tool-using systems. APIM can expose existing REST APIs as MCP servers, pass through existing MCP servers, and import A2A agent APIs. D6 uses the Responses API with tools converted from the MCP tool list, and the same gateway policies apply to Chat Completions and Responses API traffic. Stress the limits: MCP is tools-only today, not available in Consumption, and not supported inside workspaces.</a:t>
             </a:r>
             <a:endParaRPr lang="en-US" dirty="0"/>
           </a:p>
@@ -1174,7 +1174,7 @@
           <a:p>
             <a:r>
               <a:rPr lang="en-US"/>
-              <a:t>Use this divider to switch from concepts to the deployed repository. Remind the audience that the live demo uses Basic v2, two Foundry accounts, gpt-5.4-nano, product-scoped token budgets, content safety, MCP and observability.</a:t>
+              <a:t>Use this divider to switch from concepts to the deployed repository. Remind the audience that the live demo uses Basic v2, two Foundry resources plus projects, gpt-6.1-sol, product-scoped token budgets, content safety, MCP and observability.</a:t>
             </a:r>
             <a:endParaRPr lang="en-US" dirty="0"/>
           </a:p>
@@ -1262,7 +1262,7 @@
           <a:p>
             <a:r>
               <a:rPr lang="en-US"/>
-              <a:t>This is the main architecture diagram and is drawn with editable native shapes. Read it left to right: apps and agents call APIM, policies execute as a chain, model traffic goes to the Foundry backend pool, and tool traffic goes through the MCP server to the mocked Zava Retail API. Observability is emitted to Application Insights and Log Analytics.</a:t>
+              <a:t>This is the main architecture diagram and is drawn with editable native shapes. Read it left to right: apps and agents call APIM, policies execute as a chain, model traffic goes to the current Foundry resource plus project in each region, and tool traffic goes through the MCP server to the mocked Zava Retail API. APIM backends call the Foundry OpenAI v1 endpoint with managed identity and key auth disabled. Observability is emitted to Application Insights and Log Analytics.</a:t>
             </a:r>
             <a:endParaRPr lang="en-US" dirty="0"/>
           </a:p>
@@ -1438,7 +1438,7 @@
           <a:p>
             <a:r>
               <a:rPr lang="en-US"/>
-              <a:t>If the live environment is unavailable, use this as the screenshot-style talk track. D1 proves keyless backend access and stable client code with the verified France Central response. D2 proves that load balancing is active by alternating requests across Sweden Central and France Central.</a:t>
+              <a:t>If the live environment is unavailable, use this as the screenshot-style talk track. D1 proves keyless backend access and stable client code with the verified Sweden Central response: 44 prompt tokens, 94 completion tokens and 19,862 remaining. D2 proves that load balancing is active by alternating requests across France Central and Sweden Central.</a:t>
             </a:r>
             <a:endParaRPr lang="en-US" dirty="0"/>
           </a:p>
@@ -1790,7 +1790,7 @@
           <a:p>
             <a:r>
               <a:rPr lang="en-US"/>
-              <a:t>D5 proves that an existing REST API can become an MCP server through APIM. D6 then shows the agentic behavior: the model chooses to call tools via the gateway. If showing this as a fallback, read the expected answer and point back to the architecture slide.</a:t>
+              <a:t>D5 proves that an existing REST API can become an MCP server through APIM; get-order-status returns ORD-1042 as out for delivery. D6 uses the Responses API through APIM at /inference/openai/v1/responses. The client converts the MCP tool list into function tools, sends store=false, resends encrypted reasoning items for stateless load-balanced turns, and model turns were served by both France Central and Sweden Central.</a:t>
             </a:r>
             <a:endParaRPr lang="en-US" dirty="0"/>
           </a:p>
@@ -3462,7 +3462,7 @@
           <a:p>
             <a:r>
               <a:rPr lang="en-US"/>
-              <a:t>This slide is intentionally dated. The point is that APIM is not only an API product anymore; it has first-class patterns for model APIs, MCP servers and A2A agents. Cite the updated Learn pages and research brief when challenged on dates.</a:t>
+              <a:t>This slide is intentionally dated. The point is that APIM is not only an API product anymore; it has first-class patterns for model APIs, MCP servers and A2A agents. The deployed Foundry platform is the current resource plus project model in ai.azure.com, not the classic hub-based project pattern. Cite the updated Learn pages and research brief when challenged on dates.</a:t>
             </a:r>
             <a:endParaRPr lang="en-US" dirty="0"/>
           </a:p>
@@ -4247,7 +4247,7 @@
                 <a:ea typeface="Segoe UI Semibold" pitchFamily="34" charset="-122"/>
                 <a:cs typeface="Segoe UI Semibold" pitchFamily="34" charset="-120"/>
               </a:rPr>
-              <a:t>gpt-5.4-nano</a:t>
+              <a:t>gpt-6.1-sol</a:t>
             </a:r>
             <a:endParaRPr lang="en-US" sz="750" dirty="0"/>
           </a:p>
@@ -5777,7 +5777,7 @@
                 <a:ea typeface="Segoe UI Semibold" pitchFamily="34" charset="-122"/>
                 <a:cs typeface="Segoe UI Semibold" pitchFamily="34" charset="-120"/>
               </a:rPr>
-              <a:t>Demo: jailbreak blocked before it reaches gpt-5.4-nano.</a:t>
+              <a:t>Demo: jailbreak blocked before it reaches gpt-6.1-sol.</a:t>
             </a:r>
             <a:endParaRPr lang="en-US" sz="1100" dirty="0"/>
           </a:p>
@@ -8652,7 +8652,7 @@
                 <a:ea typeface="Consolas" pitchFamily="34" charset="-122"/>
                 <a:cs typeface="Consolas" pitchFamily="34" charset="-120"/>
               </a:rPr>
-              <a:t>| where DeploymentName == "gpt-5.4-nano"</a:t>
+              <a:t>| where DeploymentName == "gpt-6.1-sol"</a:t>
             </a:r>
             <a:endParaRPr lang="en-US" sz="1130" dirty="0"/>
           </a:p>
@@ -10928,7 +10928,7 @@
                 <a:ea typeface="Segoe UI Semibold" pitchFamily="34" charset="-122"/>
                 <a:cs typeface="Segoe UI Semibold" pitchFamily="34" charset="-120"/>
               </a:rPr>
-              <a:t>Zava Retail REST API becomes /zava-mcp/mcp with tools: search-products and get-order-status.</a:t>
+              <a:t>D6: Responses API turns the MCP tool list into function tools; APIM policies still apply.</a:t>
             </a:r>
             <a:endParaRPr lang="en-US" sz="1200" dirty="0"/>
           </a:p>
@@ -12134,12 +12134,12 @@
         </p:nvSpPr>
         <p:spPr>
           <a:xfrm>
-            <a:off x="8138160" y="1188720"/>
-            <a:ext cx="2651760" cy="868680"/>
+            <a:off x="7973568" y="1005840"/>
+            <a:ext cx="2971800" cy="1078992"/>
           </a:xfrm>
           <a:prstGeom prst="roundRect">
             <a:avLst>
-              <a:gd name="adj" fmla="val 6316"/>
+              <a:gd name="adj" fmla="val 5085"/>
             </a:avLst>
           </a:prstGeom>
           <a:solidFill>
@@ -12161,8 +12161,8 @@
         </p:nvSpPr>
         <p:spPr>
           <a:xfrm>
-            <a:off x="8247888" y="1280160"/>
-            <a:ext cx="2432304" cy="685800"/>
+            <a:off x="8083296" y="1097280"/>
+            <a:ext cx="2752344" cy="896112"/>
           </a:xfrm>
           <a:prstGeom prst="rect">
             <a:avLst/>
@@ -12180,7 +12180,7 @@
               <a:buNone/>
             </a:pPr>
             <a:r>
-              <a:rPr lang="en-US" sz="1000" dirty="0">
+              <a:rPr lang="en-US" sz="750" dirty="0">
                 <a:solidFill>
                   <a:srgbClr val="0B1E3F"/>
                 </a:solidFill>
@@ -12188,16 +12188,16 @@
                 <a:ea typeface="Segoe UI Semibold" pitchFamily="34" charset="-122"/>
                 <a:cs typeface="Segoe UI Semibold" pitchFamily="34" charset="-120"/>
               </a:rPr>
-              <a:t>Foundry Sweden Central</a:t>
-            </a:r>
-            <a:endParaRPr lang="en-US" sz="1000" dirty="0"/>
+              <a:t>Foundry project · Sweden Central</a:t>
+            </a:r>
+            <a:endParaRPr lang="en-US" sz="750" dirty="0"/>
           </a:p>
           <a:p>
             <a:pPr marL="0" indent="0" algn="ctr">
               <a:buNone/>
             </a:pPr>
             <a:r>
-              <a:rPr lang="en-US" sz="1000" dirty="0">
+              <a:rPr lang="en-US" sz="750" dirty="0">
                 <a:solidFill>
                   <a:srgbClr val="0B1E3F"/>
                 </a:solidFill>
@@ -12205,9 +12205,43 @@
                 <a:ea typeface="Segoe UI Semibold" pitchFamily="34" charset="-122"/>
                 <a:cs typeface="Segoe UI Semibold" pitchFamily="34" charset="-120"/>
               </a:rPr>
-              <a:t>gpt-5.4-nano</a:t>
-            </a:r>
-            <a:endParaRPr lang="en-US" sz="1000" dirty="0"/>
+              <a:t>proj-apimaigw-swc</a:t>
+            </a:r>
+            <a:endParaRPr lang="en-US" sz="750" dirty="0"/>
+          </a:p>
+          <a:p>
+            <a:pPr marL="0" indent="0" algn="ctr">
+              <a:buNone/>
+            </a:pPr>
+            <a:r>
+              <a:rPr lang="en-US" sz="750" dirty="0">
+                <a:solidFill>
+                  <a:srgbClr val="0B1E3F"/>
+                </a:solidFill>
+                <a:latin typeface="Segoe UI Semibold" pitchFamily="34" charset="0"/>
+                <a:ea typeface="Segoe UI Semibold" pitchFamily="34" charset="-122"/>
+                <a:cs typeface="Segoe UI Semibold" pitchFamily="34" charset="-120"/>
+              </a:rPr>
+              <a:t>gpt-6.1-sol · GlobalStandard</a:t>
+            </a:r>
+            <a:endParaRPr lang="en-US" sz="750" dirty="0"/>
+          </a:p>
+          <a:p>
+            <a:pPr marL="0" indent="0" algn="ctr">
+              <a:buNone/>
+            </a:pPr>
+            <a:r>
+              <a:rPr lang="en-US" sz="750" dirty="0">
+                <a:solidFill>
+                  <a:srgbClr val="0B1E3F"/>
+                </a:solidFill>
+                <a:latin typeface="Segoe UI Semibold" pitchFamily="34" charset="0"/>
+                <a:ea typeface="Segoe UI Semibold" pitchFamily="34" charset="-122"/>
+                <a:cs typeface="Segoe UI Semibold" pitchFamily="34" charset="-120"/>
+              </a:rPr>
+              <a:t>v2026-09-29 · 100K TPM</a:t>
+            </a:r>
+            <a:endParaRPr lang="en-US" sz="750" dirty="0"/>
           </a:p>
         </p:txBody>
       </p:sp>
@@ -12219,12 +12253,12 @@
         </p:nvSpPr>
         <p:spPr>
           <a:xfrm>
-            <a:off x="8138160" y="2377440"/>
-            <a:ext cx="2651760" cy="868680"/>
+            <a:off x="7973568" y="2331720"/>
+            <a:ext cx="2971800" cy="1078992"/>
           </a:xfrm>
           <a:prstGeom prst="roundRect">
             <a:avLst>
-              <a:gd name="adj" fmla="val 6316"/>
+              <a:gd name="adj" fmla="val 5085"/>
             </a:avLst>
           </a:prstGeom>
           <a:solidFill>
@@ -12246,8 +12280,8 @@
         </p:nvSpPr>
         <p:spPr>
           <a:xfrm>
-            <a:off x="8247888" y="2468880"/>
-            <a:ext cx="2432304" cy="685800"/>
+            <a:off x="8083296" y="2423160"/>
+            <a:ext cx="2752344" cy="896112"/>
           </a:xfrm>
           <a:prstGeom prst="rect">
             <a:avLst/>
@@ -12265,7 +12299,7 @@
               <a:buNone/>
             </a:pPr>
             <a:r>
-              <a:rPr lang="en-US" sz="1000" dirty="0">
+              <a:rPr lang="en-US" sz="750" dirty="0">
                 <a:solidFill>
                   <a:srgbClr val="0B1E3F"/>
                 </a:solidFill>
@@ -12273,16 +12307,16 @@
                 <a:ea typeface="Segoe UI Semibold" pitchFamily="34" charset="-122"/>
                 <a:cs typeface="Segoe UI Semibold" pitchFamily="34" charset="-120"/>
               </a:rPr>
-              <a:t>Foundry France Central</a:t>
-            </a:r>
-            <a:endParaRPr lang="en-US" sz="1000" dirty="0"/>
+              <a:t>Foundry project · France Central</a:t>
+            </a:r>
+            <a:endParaRPr lang="en-US" sz="750" dirty="0"/>
           </a:p>
           <a:p>
             <a:pPr marL="0" indent="0" algn="ctr">
               <a:buNone/>
             </a:pPr>
             <a:r>
-              <a:rPr lang="en-US" sz="1000" dirty="0">
+              <a:rPr lang="en-US" sz="750" dirty="0">
                 <a:solidFill>
                   <a:srgbClr val="0B1E3F"/>
                 </a:solidFill>
@@ -12290,9 +12324,43 @@
                 <a:ea typeface="Segoe UI Semibold" pitchFamily="34" charset="-122"/>
                 <a:cs typeface="Segoe UI Semibold" pitchFamily="34" charset="-120"/>
               </a:rPr>
-              <a:t>gpt-5.4-nano</a:t>
-            </a:r>
-            <a:endParaRPr lang="en-US" sz="1000" dirty="0"/>
+              <a:t>proj-apimaigw-frc</a:t>
+            </a:r>
+            <a:endParaRPr lang="en-US" sz="750" dirty="0"/>
+          </a:p>
+          <a:p>
+            <a:pPr marL="0" indent="0" algn="ctr">
+              <a:buNone/>
+            </a:pPr>
+            <a:r>
+              <a:rPr lang="en-US" sz="750" dirty="0">
+                <a:solidFill>
+                  <a:srgbClr val="0B1E3F"/>
+                </a:solidFill>
+                <a:latin typeface="Segoe UI Semibold" pitchFamily="34" charset="0"/>
+                <a:ea typeface="Segoe UI Semibold" pitchFamily="34" charset="-122"/>
+                <a:cs typeface="Segoe UI Semibold" pitchFamily="34" charset="-120"/>
+              </a:rPr>
+              <a:t>gpt-6.1-sol · GlobalStandard</a:t>
+            </a:r>
+            <a:endParaRPr lang="en-US" sz="750" dirty="0"/>
+          </a:p>
+          <a:p>
+            <a:pPr marL="0" indent="0" algn="ctr">
+              <a:buNone/>
+            </a:pPr>
+            <a:r>
+              <a:rPr lang="en-US" sz="750" dirty="0">
+                <a:solidFill>
+                  <a:srgbClr val="0B1E3F"/>
+                </a:solidFill>
+                <a:latin typeface="Segoe UI Semibold" pitchFamily="34" charset="0"/>
+                <a:ea typeface="Segoe UI Semibold" pitchFamily="34" charset="-122"/>
+                <a:cs typeface="Segoe UI Semibold" pitchFamily="34" charset="-120"/>
+              </a:rPr>
+              <a:t>v2026-09-29 · 100K TPM</a:t>
+            </a:r>
+            <a:endParaRPr lang="en-US" sz="750" dirty="0"/>
           </a:p>
         </p:txBody>
       </p:sp>
@@ -12583,8 +12651,8 @@
         </p:nvSpPr>
         <p:spPr>
           <a:xfrm>
-            <a:off x="7040880" y="1627632"/>
-            <a:ext cx="1097280" cy="0"/>
+            <a:off x="7040880" y="1545336"/>
+            <a:ext cx="932688" cy="0"/>
           </a:xfrm>
           <a:prstGeom prst="line">
             <a:avLst/>
@@ -12607,8 +12675,8 @@
         </p:nvSpPr>
         <p:spPr>
           <a:xfrm>
-            <a:off x="7040880" y="2816352"/>
-            <a:ext cx="1097280" cy="0"/>
+            <a:off x="7040880" y="2871216"/>
+            <a:ext cx="932688" cy="0"/>
           </a:xfrm>
           <a:prstGeom prst="line">
             <a:avLst/>
@@ -13156,7 +13224,7 @@
                 <a:ea typeface="Segoe UI" pitchFamily="34" charset="-122"/>
                 <a:cs typeface="Segoe UI" pitchFamily="34" charset="-120"/>
               </a:rPr>
-              <a:t>200 via France Central; token headers show 44 prompt / 51 completion and 19,905 remaining.</a:t>
+              <a:t>200 via Sweden Central; token headers show 44 prompt / 94 completion and 19,862 remaining.</a:t>
             </a:r>
             <a:endParaRPr lang="en-US" sz="820" dirty="0"/>
           </a:p>
@@ -13288,7 +13356,7 @@
                 <a:ea typeface="Segoe UI" pitchFamily="34" charset="-122"/>
                 <a:cs typeface="Segoe UI" pitchFamily="34" charset="-120"/>
               </a:rPr>
-              <a:t>Six calls spread across Sweden Central and France Central; circuit breaker explained.</a:t>
+              <a:t>Six calls alternate France Central and Sweden Central; circuit breaker explained.</a:t>
             </a:r>
             <a:endParaRPr lang="en-US" sz="820" dirty="0"/>
           </a:p>
@@ -13420,7 +13488,7 @@
                 <a:ea typeface="Segoe UI" pitchFamily="34" charset="-122"/>
                 <a:cs typeface="Segoe UI" pitchFamily="34" charset="-120"/>
               </a:rPr>
-              <a:t>Bronze hits 429 with Retry-After; Gold continues; monthly quota returns 403.</a:t>
+              <a:t>Bronze returns 200 x6 then 429 Retry-After 11; Gold continues.</a:t>
             </a:r>
             <a:endParaRPr lang="en-US" sz="820" dirty="0"/>
           </a:p>
@@ -13816,7 +13884,7 @@
                 <a:ea typeface="Segoe UI" pitchFamily="34" charset="-122"/>
                 <a:cs typeface="Segoe UI" pitchFamily="34" charset="-120"/>
               </a:rPr>
-              <a:t>Model calls MCP tools via gateway to answer product and order questions.</a:t>
+              <a:t>Responses API converts MCP tools to function tools; store=false keeps it stateless.</a:t>
             </a:r>
             <a:endParaRPr lang="en-US" sz="820" dirty="0"/>
           </a:p>
@@ -13948,7 +14016,7 @@
                 <a:ea typeface="Segoe UI" pitchFamily="34" charset="-122"/>
                 <a:cs typeface="Segoe UI" pitchFamily="34" charset="-120"/>
               </a:rPr>
-              <a:t>AppMetrics by Product and ApiManagementGatewayLlmLog by DeploymentName gpt-5.4-nano.</a:t>
+              <a:t>AppMetrics by Product and ApiManagementGatewayLlmLog by DeploymentName gpt-6.1-sol.</a:t>
             </a:r>
             <a:endParaRPr lang="en-US" sz="820" dirty="0"/>
           </a:p>
@@ -14569,7 +14637,7 @@
                 <a:ea typeface="Segoe UI" pitchFamily="34" charset="-122"/>
                 <a:cs typeface="Segoe UI" pitchFamily="34" charset="-120"/>
               </a:rPr>
-              <a:t>HTTP 200 via France Central. App uses only an APIM subscription key; APIM authenticates to Foundry with managed identity.</a:t>
+              <a:t>HTTP 200 via Sweden Central. App uses only an APIM subscription key; APIM authenticates to Foundry with managed identity.</a:t>
             </a:r>
             <a:endParaRPr lang="en-US" sz="1020" dirty="0"/>
           </a:p>
@@ -14772,7 +14840,7 @@
                 <a:ea typeface="Segoe UI" pitchFamily="34" charset="-122"/>
                 <a:cs typeface="Segoe UI" pitchFamily="34" charset="-120"/>
               </a:rPr>
-              <a:t>Six requests alternate Sweden Central / France Central. Circuit breaker remains ready for 429/5xx failover.</a:t>
+              <a:t>Six requests alternate France Central / Sweden Central. Circuit breaker remains ready for 429/5xx failover.</a:t>
             </a:r>
             <a:endParaRPr lang="en-US" sz="1020" dirty="0"/>
           </a:p>
@@ -14838,7 +14906,7 @@
                 <a:ea typeface="Consolas" pitchFamily="34" charset="-122"/>
                 <a:cs typeface="Consolas" pitchFamily="34" charset="-120"/>
               </a:rPr>
-              <a:t>D1: 200 OK · region=francecentral · prompt=44 · completion=51 · remaining=19905</a:t>
+              <a:t>D1: 200 OK · region=swedencentral · prompt=44 · completion=94 · remaining=19862</a:t>
             </a:r>
             <a:endParaRPr lang="en-US" sz="1000" dirty="0"/>
           </a:p>
@@ -14855,7 +14923,7 @@
                 <a:ea typeface="Consolas" pitchFamily="34" charset="-122"/>
                 <a:cs typeface="Consolas" pitchFamily="34" charset="-120"/>
               </a:rPr>
-              <a:t>D2: swedencentral → francecentral → swedencentral → francecentral → swedencentral → francecentral</a:t>
+              <a:t>D2: francecentral → swedencentral → francecentral → swedencentral → francecentral → swedencentral</a:t>
             </a:r>
             <a:endParaRPr lang="en-US" sz="1000" dirty="0"/>
           </a:p>
@@ -17497,7 +17565,7 @@
                 <a:ea typeface="Segoe UI" pitchFamily="34" charset="-122"/>
                 <a:cs typeface="Segoe UI" pitchFamily="34" charset="-120"/>
               </a:rPr>
-              <a:t>Bronze returns 200 five times, then 429 with Retry-After; Gold still returns 200.</a:t>
+              <a:t>Bronze returns 200 six times, then 429 with Retry-After 11; Gold still returns 200.</a:t>
             </a:r>
             <a:endParaRPr lang="en-US" sz="1040" dirty="0"/>
           </a:p>
@@ -17563,7 +17631,7 @@
                 <a:ea typeface="Consolas" pitchFamily="34" charset="-122"/>
                 <a:cs typeface="Consolas" pitchFamily="34" charset="-120"/>
               </a:rPr>
-              <a:t>Bronze calls: 200 x5 · remaining tokens: 228, 162, 104, 52, 0</a:t>
+              <a:t>Bronze calls: 200 x6 · remaining: 239, 176, 123, 81, 9, 0</a:t>
             </a:r>
             <a:endParaRPr lang="en-US" sz="1210" dirty="0"/>
           </a:p>
@@ -17580,7 +17648,7 @@
                 <a:ea typeface="Consolas" pitchFamily="34" charset="-122"/>
                 <a:cs typeface="Consolas" pitchFamily="34" charset="-120"/>
               </a:rPr>
-              <a:t>Then: HTTP/1.1 429 Too Many Requests · Retry-After returned</a:t>
+              <a:t>Then: HTTP/1.1 429 Too Many Requests · Retry-After: 11</a:t>
             </a:r>
             <a:endParaRPr lang="en-US" sz="1210" dirty="0"/>
           </a:p>
@@ -18057,7 +18125,7 @@
                 <a:ea typeface="Segoe UI" pitchFamily="34" charset="-122"/>
                 <a:cs typeface="Segoe UI" pitchFamily="34" charset="-120"/>
               </a:rPr>
-              <a:t>Verified HTTP 200; forwarded through APIM to gpt-5.4-nano.</a:t>
+              <a:t>Verified HTTP 200; forwarded through APIM to gpt-6.1-sol.</a:t>
             </a:r>
             <a:endParaRPr lang="en-US" sz="1050" dirty="0"/>
           </a:p>
@@ -18965,7 +19033,7 @@
                 <a:ea typeface="Segoe UI Semibold" pitchFamily="34" charset="-122"/>
                 <a:cs typeface="Segoe UI Semibold" pitchFamily="34" charset="-120"/>
               </a:rPr>
-              <a:t>D6: model decides</a:t>
+              <a:t>D6: Responses API</a:t>
             </a:r>
             <a:endParaRPr lang="en-US" sz="1250" dirty="0"/>
           </a:p>
@@ -19006,7 +19074,7 @@
                 <a:ea typeface="Segoe UI" pitchFamily="34" charset="-122"/>
                 <a:cs typeface="Segoe UI" pitchFamily="34" charset="-120"/>
               </a:rPr>
-              <a:t>Agent called both MCP tools through the gateway and composed the answer.</a:t>
+              <a:t>Agent converted MCP tools into function tools; store=false keeps the turn stateless.</a:t>
             </a:r>
             <a:endParaRPr lang="en-US" sz="1040" dirty="0"/>
           </a:p>
@@ -19189,7 +19257,7 @@
                 <a:ea typeface="Consolas" pitchFamily="34" charset="-122"/>
                 <a:cs typeface="Consolas" pitchFamily="34" charset="-120"/>
               </a:rPr>
-              <a:t>"Trail backpack 30L (€89.9) and Headlamp 400lm (€34.5) are under 100 EUR.</a:t>
+              <a:t>"Trail backpack 30L (€89.90) and Headlamp 400lm (€34.50) are under 100 EUR.</a:t>
             </a:r>
             <a:endParaRPr lang="en-US" sz="1020" dirty="0"/>
           </a:p>
@@ -19206,7 +19274,7 @@
                 <a:ea typeface="Consolas" pitchFamily="34" charset="-122"/>
                 <a:cs typeface="Consolas" pitchFamily="34" charset="-120"/>
               </a:rPr>
-              <a:t>ORD-1042 is Out for delivery with Zava Express."</a:t>
+              <a:t>ORD-1042 is out for delivery with Zava Express."</a:t>
             </a:r>
             <a:endParaRPr lang="en-US" sz="1020" dirty="0"/>
           </a:p>
@@ -19869,7 +19937,7 @@
                 <a:ea typeface="Segoe UI" pitchFamily="34" charset="-122"/>
                 <a:cs typeface="Segoe UI" pitchFamily="34" charset="-120"/>
               </a:rPr>
-              <a:t>ApiManagementGatewayLlmLog groups calls by DeploymentName: gpt-5.4-nano.</a:t>
+              <a:t>ApiManagementGatewayLlmLog groups calls by DeploymentName: gpt-6.1-sol.</a:t>
             </a:r>
             <a:endParaRPr lang="en-US" sz="1040" dirty="0"/>
           </a:p>
@@ -20155,7 +20223,7 @@
                 <a:ea typeface="Consolas" pitchFamily="34" charset="-122"/>
                 <a:cs typeface="Consolas" pitchFamily="34" charset="-120"/>
               </a:rPr>
-              <a:t>ApiManagementGatewayLlmLog | summarize Calls=count() by DeploymentName   // gpt-5.4-nano</a:t>
+              <a:t>ApiManagementGatewayLlmLog | summarize Calls=count() by DeploymentName   // gpt-6.1-sol</a:t>
             </a:r>
             <a:endParaRPr lang="en-US" sz="1060" dirty="0"/>
           </a:p>
@@ -37790,7 +37858,7 @@
                 <a:ea typeface="Segoe UI Semibold" pitchFamily="34" charset="-122"/>
                 <a:cs typeface="Segoe UI Semibold" pitchFamily="34" charset="-120"/>
               </a:rPr>
-              <a:t>2026 preview</a:t>
+              <a:t>Oct 2026</a:t>
             </a:r>
             <a:endParaRPr lang="en-US" sz="1000" dirty="0"/>
           </a:p>
@@ -37831,7 +37899,7 @@
                 <a:ea typeface="Segoe UI" pitchFamily="34" charset="-122"/>
                 <a:cs typeface="Segoe UI" pitchFamily="34" charset="-120"/>
               </a:rPr>
-              <a:t>Unified model API and Foundry-integrated AI gateway.</a:t>
+              <a:t>Foundry (new): resource + project per region in ai.azure.com; no classic hub or Azure OpenAI resource.</a:t>
             </a:r>
             <a:endParaRPr lang="en-US" sz="1120" dirty="0"/>
           </a:p>

</xml_diff>